<commit_message>
Project Presentation errors 2
</commit_message>
<xml_diff>
--- a/Project-Presentation.pptx
+++ b/Project-Presentation.pptx
@@ -77,7 +77,7 @@
         <p:txBody>
           <a:bodyPr/>
           <a:p>
-            <a:fld id="{0ABF5EFF-3032-42AF-BD55-FCE13095596A}" type="slidenum">
+            <a:fld id="{688C29A4-D6ED-4273-A257-75CD2C6D242A}" type="slidenum">
               <a:t>&lt;#&gt;</a:t>
             </a:fld>
           </a:p>
@@ -286,7 +286,7 @@
         <p:txBody>
           <a:bodyPr/>
           <a:p>
-            <a:fld id="{AADBE235-0454-46B0-9A38-E5B2B559A9C5}" type="slidenum">
+            <a:fld id="{CAD66A21-0697-4872-A170-B46023561DB9}" type="slidenum">
               <a:t>&lt;#&gt;</a:t>
             </a:fld>
           </a:p>
@@ -581,7 +581,7 @@
         <p:txBody>
           <a:bodyPr/>
           <a:p>
-            <a:fld id="{A5F97A62-8437-4341-A4C6-2026E45F4EA7}" type="slidenum">
+            <a:fld id="{121E7648-3F26-4912-98A4-8A0D5CD3B838}" type="slidenum">
               <a:t>&lt;#&gt;</a:t>
             </a:fld>
           </a:p>
@@ -962,7 +962,7 @@
         <p:txBody>
           <a:bodyPr/>
           <a:p>
-            <a:fld id="{87A84A23-DFCF-463B-AB4D-3C4267E1E02C}" type="slidenum">
+            <a:fld id="{2D5F3E15-DDA0-4F94-8CB5-054A8B8FE66D}" type="slidenum">
               <a:t>&lt;#&gt;</a:t>
             </a:fld>
           </a:p>
@@ -1125,7 +1125,7 @@
         <p:txBody>
           <a:bodyPr/>
           <a:p>
-            <a:fld id="{FBD2B853-7AFA-4225-B28F-B9C1F46C8164}" type="slidenum">
+            <a:fld id="{3833A930-51C2-4E53-8235-36CC5B3FAFBA}" type="slidenum">
               <a:t>&lt;#&gt;</a:t>
             </a:fld>
           </a:p>
@@ -1291,7 +1291,7 @@
         <p:txBody>
           <a:bodyPr/>
           <a:p>
-            <a:fld id="{E54A1C9E-9D20-412C-AFB3-DD33DAF82ED8}" type="slidenum">
+            <a:fld id="{873098FD-1C72-4466-A6CE-B754EC423F9C}" type="slidenum">
               <a:t>&lt;#&gt;</a:t>
             </a:fld>
           </a:p>
@@ -1500,7 +1500,7 @@
         <p:txBody>
           <a:bodyPr/>
           <a:p>
-            <a:fld id="{88C0CAEF-8930-47F3-9E87-AF9FB651722D}" type="slidenum">
+            <a:fld id="{5FF034F6-983B-477D-A26B-5203B5BF146B}" type="slidenum">
               <a:t>&lt;#&gt;</a:t>
             </a:fld>
           </a:p>
@@ -1623,7 +1623,7 @@
         <p:txBody>
           <a:bodyPr/>
           <a:p>
-            <a:fld id="{793F5C56-1FEC-4799-B38B-7C5D7F9BEE28}" type="slidenum">
+            <a:fld id="{B8F30DA4-4FB2-45FD-823A-B80EF4F18E1B}" type="slidenum">
               <a:t>&lt;#&gt;</a:t>
             </a:fld>
           </a:p>
@@ -1744,7 +1744,7 @@
         <p:txBody>
           <a:bodyPr/>
           <a:p>
-            <a:fld id="{652B305A-4124-407E-9DA7-05BC74BC4A99}" type="slidenum">
+            <a:fld id="{B6FE461C-7160-4FDA-9134-E02CD2C361F1}" type="slidenum">
               <a:t>&lt;#&gt;</a:t>
             </a:fld>
           </a:p>
@@ -1996,7 +1996,7 @@
         <p:txBody>
           <a:bodyPr/>
           <a:p>
-            <a:fld id="{7A5CE4A9-B1B8-41D3-8D08-0A2A3366013E}" type="slidenum">
+            <a:fld id="{8E993410-461E-4133-B167-02A9D3FB05C3}" type="slidenum">
               <a:t>&lt;#&gt;</a:t>
             </a:fld>
           </a:p>
@@ -2248,7 +2248,7 @@
         <p:txBody>
           <a:bodyPr/>
           <a:p>
-            <a:fld id="{E6C91626-8661-48E6-AD57-8876BC8E5BCB}" type="slidenum">
+            <a:fld id="{E99348F1-766B-409E-8C2D-DC9C6E3ECBC4}" type="slidenum">
               <a:t>&lt;#&gt;</a:t>
             </a:fld>
           </a:p>
@@ -2500,7 +2500,7 @@
         <p:txBody>
           <a:bodyPr/>
           <a:p>
-            <a:fld id="{861262E6-3668-4D79-87EA-B52AD2AD90C0}" type="slidenum">
+            <a:fld id="{51F8161D-35C6-47F4-881B-AD3E6CF4A62B}" type="slidenum">
               <a:t>&lt;#&gt;</a:t>
             </a:fld>
           </a:p>
@@ -2611,7 +2611,7 @@
                 </a:solidFill>
                 <a:latin typeface="Calibri"/>
               </a:rPr>
-              <a:t>&lt;date/time&gt;</a:t>
+              <a:t> </a:t>
             </a:r>
             <a:endParaRPr b="0" lang="es-ES" sz="1200" spc="-1" strike="noStrike">
               <a:solidFill>
@@ -2671,7 +2671,7 @@
                 </a:solidFill>
                 <a:latin typeface="Times New Roman"/>
               </a:rPr>
-              <a:t>&lt;footer&gt;</a:t>
+              <a:t> </a:t>
             </a:r>
             <a:endParaRPr b="0" lang="es-ES" sz="1400" spc="-1" strike="noStrike">
               <a:solidFill>
@@ -2730,14 +2730,14 @@
               </a:lnSpc>
               <a:buNone/>
             </a:pPr>
-            <a:fld id="{C3D1414E-82A2-41F6-BBC6-1FE2DA620B7E}" type="slidenum">
+            <a:fld id="{7C3475EA-0A2B-4AEE-9244-7EC01FB56416}" type="slidenum">
               <a:rPr b="0" lang="en-US" sz="1200" spc="-1" strike="noStrike">
                 <a:solidFill>
                   <a:srgbClr val="8b8b8b"/>
                 </a:solidFill>
                 <a:latin typeface="Calibri"/>
               </a:rPr>
-              <a:t>&lt;number&gt;</a:t>
+              <a:t>10</a:t>
             </a:fld>
             <a:endParaRPr b="0" lang="es-ES" sz="1200" spc="-1" strike="noStrike">
               <a:solidFill>
@@ -3298,7 +3298,28 @@
                 <a:latin typeface="Montserrat"/>
                 <a:ea typeface="Montserrat"/>
               </a:rPr>
-              <a:t>JOAQUIN AVILES DE LA FUENTE</a:t>
+              <a:t>JOAQUIN </a:t>
+            </a:r>
+            <a:r>
+              <a:rPr b="0" lang="en-US" sz="2200" spc="-1" strike="noStrike" u="sng">
+                <a:solidFill>
+                  <a:srgbClr val="4d4b66"/>
+                </a:solidFill>
+                <a:uFillTx/>
+                <a:latin typeface="Montserrat"/>
+                <a:ea typeface="Montserrat"/>
+              </a:rPr>
+              <a:t>AVILES</a:t>
+            </a:r>
+            <a:r>
+              <a:rPr b="0" lang="en-US" sz="2200" spc="-1" strike="noStrike">
+                <a:solidFill>
+                  <a:srgbClr val="4d4b66"/>
+                </a:solidFill>
+                <a:latin typeface="Montserrat"/>
+                <a:ea typeface="Montserrat"/>
+              </a:rPr>
+              <a:t> DE LA FUENTE</a:t>
             </a:r>
             <a:endParaRPr b="0" lang="es-ES" sz="2200" spc="-1" strike="noStrike">
               <a:solidFill>
@@ -11048,7 +11069,7 @@
                   <a:latin typeface="Open Sans 1 Bold"/>
                   <a:ea typeface="Open Sans 1 Bold"/>
                 </a:rPr>
-                <a:t>Redigitized</a:t>
+                <a:t>Redigitalized</a:t>
               </a:r>
               <a:endParaRPr b="0" lang="es-ES" sz="1800" spc="-1" strike="noStrike">
                 <a:solidFill>

</xml_diff>